<commit_message>
Add six course-end game quests and connect lesson completion
</commit_message>
<xml_diff>
--- a/assets/teaching/app-slides.pptx
+++ b/assets/teaching/app-slides.pptx
@@ -21,6 +21,7 @@
     <p:sldId id="269" r:id="rId21"/>
     <p:sldId id="270" r:id="rId22"/>
     <p:sldId id="271" r:id="rId23"/>
+    <p:sldId id="272" r:id="rId24"/>
   </p:sldIdLst>
   <p:sldSz cx="12191695" cy="6858000" type="screen4x3"/>
   <p:notesSz cx="6858000" cy="9144000"/>
@@ -963,6 +964,76 @@
 </file>
 
 <file path=ppt/notesSlides/notesSlide16.xml><?xml version="1.0" encoding="utf-8"?>
+<p:notes xmlns:a="http://schemas.openxmlformats.org/drawingml/2006/main" xmlns:p="http://schemas.openxmlformats.org/presentationml/2006/main" xmlns:r="http://schemas.openxmlformats.org/officeDocument/2006/relationships">
+  <p:cSld>
+    <p:spTree>
+      <p:nvGrpSpPr>
+        <p:cNvPr id="1" name=""/>
+        <p:cNvGrpSpPr/>
+        <p:nvPr/>
+      </p:nvGrpSpPr>
+      <p:grpSpPr>
+        <a:xfrm>
+          <a:off x="0" y="0"/>
+          <a:ext cx="0" cy="0"/>
+          <a:chOff x="0" y="0"/>
+          <a:chExt cx="0" cy="0"/>
+        </a:xfrm>
+      </p:grpSpPr>
+      <p:sp>
+        <p:nvSpPr>
+          <p:cNvPr id="2" name="Slide Image Placeholder 1"/>
+          <p:cNvSpPr>
+            <a:spLocks noGrp="1"/>
+          </p:cNvSpPr>
+          <p:nvPr>
+            <p:ph type="sldImg" idx="2"/>
+          </p:nvPr>
+        </p:nvSpPr>
+        <p:spPr/>
+      </p:sp>
+      <p:sp>
+        <p:nvSpPr>
+          <p:cNvPr id="3" name="Notes Placeholder 2"/>
+          <p:cNvSpPr>
+            <a:spLocks noGrp="1"/>
+          </p:cNvSpPr>
+          <p:nvPr>
+            <p:ph type="body" idx="3" sz="quarter"/>
+          </p:nvPr>
+        </p:nvSpPr>
+        <p:spPr/>
+        <p:txBody>
+          <a:bodyPr/>
+          <a:lstStyle/>
+          <a:p>
+            <a:r>
+              <a:t>마무리 시간에 교재의 마지막 게임 도전 링크를 엽니다. 전원을 기다리며 답을 대신 고르지 않습니다. 학습자가 왜 그 행동이 맞는지 설명하게 하세요. 실습 체크와 게임 클리어를 모두 마쳐야 과정 마무리로 표시됩니다. 게임 기록은 현재 브라우저에만 남으며 강사에게 자동 제출되지 않습니다.</a:t>
+            </a:r>
+          </a:p>
+        </p:txBody>
+      </p:sp>
+      <p:sp>
+        <p:nvSpPr>
+          <p:cNvPr id="4" name="Slide Number Placeholder 3"/>
+          <p:cNvSpPr>
+            <a:spLocks noGrp="1"/>
+          </p:cNvSpPr>
+          <p:nvPr>
+            <p:ph type="sldNum" idx="5" sz="quarter"/>
+          </p:nvPr>
+        </p:nvSpPr>
+        <p:spPr/>
+      </p:sp>
+    </p:spTree>
+  </p:cSld>
+  <p:clrMapOvr>
+    <a:masterClrMapping/>
+  </p:clrMapOvr>
+</p:notes>
+</file>
+
+<file path=ppt/notesSlides/notesSlide17.xml><?xml version="1.0" encoding="utf-8"?>
 <p:notes xmlns:a="http://schemas.openxmlformats.org/drawingml/2006/main" xmlns:p="http://schemas.openxmlformats.org/presentationml/2006/main" xmlns:r="http://schemas.openxmlformats.org/officeDocument/2006/relationships">
   <p:cSld>
     <p:spTree>
@@ -4805,7 +4876,7 @@
               </a:defRPr>
             </a:pPr>
             <a:r>
-              <a:t>01 / 16</a:t>
+              <a:t>01 / 17</a:t>
             </a:r>
           </a:p>
         </p:txBody>
@@ -5079,7 +5150,7 @@
               </a:defRPr>
             </a:pPr>
             <a:r>
-              <a:t>10 / 16</a:t>
+              <a:t>10 / 17</a:t>
             </a:r>
           </a:p>
         </p:txBody>
@@ -5334,7 +5405,7 @@
               </a:defRPr>
             </a:pPr>
             <a:r>
-              <a:t>11 / 16</a:t>
+              <a:t>11 / 17</a:t>
             </a:r>
           </a:p>
         </p:txBody>
@@ -5589,7 +5660,7 @@
               </a:defRPr>
             </a:pPr>
             <a:r>
-              <a:t>12 / 16</a:t>
+              <a:t>12 / 17</a:t>
             </a:r>
           </a:p>
         </p:txBody>
@@ -5863,7 +5934,7 @@
               </a:defRPr>
             </a:pPr>
             <a:r>
-              <a:t>13 / 16</a:t>
+              <a:t>13 / 17</a:t>
             </a:r>
           </a:p>
         </p:txBody>
@@ -6156,7 +6227,7 @@
               </a:defRPr>
             </a:pPr>
             <a:r>
-              <a:t>14 / 16</a:t>
+              <a:t>14 / 17</a:t>
             </a:r>
           </a:p>
         </p:txBody>
@@ -6392,7 +6463,7 @@
               </a:defRPr>
             </a:pPr>
             <a:r>
-              <a:t>15 / 16</a:t>
+              <a:t>15 / 17</a:t>
             </a:r>
           </a:p>
         </p:txBody>
@@ -6460,7 +6531,7 @@
               </a:defRPr>
             </a:pPr>
             <a:r>
-              <a:t>CLASS 06 / NEXT DAY</a:t>
+              <a:t>CLASS 06 / FINAL QUEST</a:t>
             </a:r>
           </a:p>
         </p:txBody>
@@ -6502,14 +6573,16 @@
               </a:defRPr>
             </a:pPr>
             <a:r>
-              <a:t>내일, 내 일에 한 번 더</a:t>
-            </a:r>
-          </a:p>
-        </p:txBody>
-      </p:sp>
-      <p:sp>
-        <p:nvSpPr>
-          <p:cNvPr id="4" name="TextBox 3"/>
+              <a:t>사라지는 기록을 지켜라</a:t>
+            </a:r>
+          </a:p>
+        </p:txBody>
+      </p:sp>
+      <p:sp>
+        <p:nvSpPr>
+          <p:cNvPr id="4" name="TextBox 3">
+            <a:hlinkClick r:id="rId2"/>
+          </p:cNvPr>
           <p:cNvSpPr txBox="1"/>
           <p:nvPr/>
         </p:nvSpPr>
@@ -6544,7 +6617,7 @@
               </a:defRPr>
             </a:pPr>
             <a:r>
-              <a:t>• 불편 하나를 골라 백업 후 수정합니다. 이전에 통과한 추가·완료·삭제·재열기가 그대로 되는지 확인합니다.</a:t>
+              <a:t>• 실습 뒤 6개 상황 미션을 해결하고 보스를 클리어하세요.</a:t>
             </a:r>
           </a:p>
           <a:p>
@@ -6563,7 +6636,31 @@
               </a:defRPr>
             </a:pPr>
             <a:r>
-              <a:t>• 탭을 닫았다 열어도 왜 기록이 남나요? 다른 기기에도 같은 기록이 자동으로 보일까요?</a:t>
+              <a:t>• 틀린 문제는 해설과 힌트로 다시 도전합니다. 실제 실습 결과도 함께 확인하세요.</a:t>
+            </a:r>
+          </a:p>
+          <a:p>
+            <a:pPr>
+              <a:lnSpc>
+                <a:spcPct val="122000"/>
+              </a:lnSpc>
+              <a:spcAft>
+                <a:spcPts val="900"/>
+              </a:spcAft>
+              <a:defRPr sz="2300" b="0">
+                <a:solidFill>
+                  <a:srgbClr val="DBE5F0"/>
+                </a:solidFill>
+                <a:latin typeface="맑은 고딕"/>
+              </a:defRPr>
+            </a:pPr>
+            <a:r>
+              <a:rPr u="sng">
+                <a:solidFill>
+                  <a:srgbClr val="DBE5F0"/>
+                </a:solidFill>
+              </a:rPr>
+              <a:t>• https://aihubos.github.io/builderslab-curriculum/mission-app.html</a:t>
             </a:r>
           </a:p>
         </p:txBody>
@@ -6647,7 +6744,262 @@
               </a:defRPr>
             </a:pPr>
             <a:r>
-              <a:t>16 / 16</a:t>
+              <a:t>16 / 17</a:t>
+            </a:r>
+          </a:p>
+        </p:txBody>
+      </p:sp>
+    </p:spTree>
+  </p:cSld>
+  <p:clrMapOvr>
+    <a:masterClrMapping/>
+  </p:clrMapOvr>
+</p:sld>
+</file>
+
+<file path=ppt/slides/slide17.xml><?xml version="1.0" encoding="utf-8"?>
+<p:sld xmlns:a="http://schemas.openxmlformats.org/drawingml/2006/main" xmlns:p="http://schemas.openxmlformats.org/presentationml/2006/main" xmlns:r="http://schemas.openxmlformats.org/officeDocument/2006/relationships">
+  <p:cSld>
+    <p:bg>
+      <p:bgPr>
+        <a:solidFill>
+          <a:srgbClr val="071126"/>
+        </a:solidFill>
+        <a:effectLst/>
+      </p:bgPr>
+    </p:bg>
+    <p:spTree>
+      <p:nvGrpSpPr>
+        <p:cNvPr id="1" name=""/>
+        <p:cNvGrpSpPr/>
+        <p:nvPr/>
+      </p:nvGrpSpPr>
+      <p:grpSpPr/>
+      <p:sp>
+        <p:nvSpPr>
+          <p:cNvPr id="2" name="TextBox 1"/>
+          <p:cNvSpPr txBox="1"/>
+          <p:nvPr/>
+        </p:nvSpPr>
+        <p:spPr>
+          <a:xfrm>
+            <a:off x="640080" y="384048"/>
+            <a:ext cx="10698480" cy="320040"/>
+          </a:xfrm>
+          <a:prstGeom prst="rect">
+            <a:avLst/>
+          </a:prstGeom>
+          <a:noFill/>
+        </p:spPr>
+        <p:txBody>
+          <a:bodyPr wrap="square" lIns="0" rIns="0" tIns="0" bIns="0">
+            <a:spAutoFit/>
+          </a:bodyPr>
+          <a:lstStyle/>
+          <a:p>
+            <a:pPr>
+              <a:lnSpc>
+                <a:spcPct val="122000"/>
+              </a:lnSpc>
+              <a:spcAft>
+                <a:spcPts val="900"/>
+              </a:spcAft>
+              <a:defRPr sz="1200" b="1">
+                <a:solidFill>
+                  <a:srgbClr val="C8FF32"/>
+                </a:solidFill>
+                <a:latin typeface="맑은 고딕"/>
+              </a:defRPr>
+            </a:pPr>
+            <a:r>
+              <a:t>CLASS 06 / NEXT DAY</a:t>
+            </a:r>
+          </a:p>
+        </p:txBody>
+      </p:sp>
+      <p:sp>
+        <p:nvSpPr>
+          <p:cNvPr id="3" name="TextBox 2"/>
+          <p:cNvSpPr txBox="1"/>
+          <p:nvPr/>
+        </p:nvSpPr>
+        <p:spPr>
+          <a:xfrm>
+            <a:off x="640080" y="914400"/>
+            <a:ext cx="10881360" cy="1645920"/>
+          </a:xfrm>
+          <a:prstGeom prst="rect">
+            <a:avLst/>
+          </a:prstGeom>
+          <a:noFill/>
+        </p:spPr>
+        <p:txBody>
+          <a:bodyPr wrap="square" lIns="0" rIns="0" tIns="0" bIns="0">
+            <a:spAutoFit/>
+          </a:bodyPr>
+          <a:lstStyle/>
+          <a:p>
+            <a:pPr>
+              <a:lnSpc>
+                <a:spcPct val="122000"/>
+              </a:lnSpc>
+              <a:spcAft>
+                <a:spcPts val="900"/>
+              </a:spcAft>
+              <a:defRPr sz="3800" b="1">
+                <a:solidFill>
+                  <a:srgbClr val="FFFFFF"/>
+                </a:solidFill>
+                <a:latin typeface="맑은 고딕"/>
+              </a:defRPr>
+            </a:pPr>
+            <a:r>
+              <a:t>내일, 내 일에 한 번 더</a:t>
+            </a:r>
+          </a:p>
+        </p:txBody>
+      </p:sp>
+      <p:sp>
+        <p:nvSpPr>
+          <p:cNvPr id="4" name="TextBox 3"/>
+          <p:cNvSpPr txBox="1"/>
+          <p:nvPr/>
+        </p:nvSpPr>
+        <p:spPr>
+          <a:xfrm>
+            <a:off x="731520" y="2606040"/>
+            <a:ext cx="10698480" cy="3200400"/>
+          </a:xfrm>
+          <a:prstGeom prst="rect">
+            <a:avLst/>
+          </a:prstGeom>
+          <a:noFill/>
+        </p:spPr>
+        <p:txBody>
+          <a:bodyPr wrap="square" lIns="0" rIns="0" tIns="0" bIns="0">
+            <a:spAutoFit/>
+          </a:bodyPr>
+          <a:lstStyle/>
+          <a:p>
+            <a:pPr>
+              <a:lnSpc>
+                <a:spcPct val="122000"/>
+              </a:lnSpc>
+              <a:spcAft>
+                <a:spcPts val="900"/>
+              </a:spcAft>
+              <a:defRPr sz="2300" b="0">
+                <a:solidFill>
+                  <a:srgbClr val="DBE5F0"/>
+                </a:solidFill>
+                <a:latin typeface="맑은 고딕"/>
+              </a:defRPr>
+            </a:pPr>
+            <a:r>
+              <a:t>• 불편 하나를 골라 백업 후 수정합니다. 이전에 통과한 추가·완료·삭제·재열기가 그대로 되는지 확인합니다.</a:t>
+            </a:r>
+          </a:p>
+          <a:p>
+            <a:pPr>
+              <a:lnSpc>
+                <a:spcPct val="122000"/>
+              </a:lnSpc>
+              <a:spcAft>
+                <a:spcPts val="900"/>
+              </a:spcAft>
+              <a:defRPr sz="2300" b="0">
+                <a:solidFill>
+                  <a:srgbClr val="DBE5F0"/>
+                </a:solidFill>
+                <a:latin typeface="맑은 고딕"/>
+              </a:defRPr>
+            </a:pPr>
+            <a:r>
+              <a:t>• 탭을 닫았다 열어도 왜 기록이 남나요? 다른 기기에도 같은 기록이 자동으로 보일까요?</a:t>
+            </a:r>
+          </a:p>
+        </p:txBody>
+      </p:sp>
+      <p:sp>
+        <p:nvSpPr>
+          <p:cNvPr id="5" name="TextBox 4"/>
+          <p:cNvSpPr txBox="1"/>
+          <p:nvPr/>
+        </p:nvSpPr>
+        <p:spPr>
+          <a:xfrm>
+            <a:off x="640080" y="6364224"/>
+            <a:ext cx="9601200" cy="228600"/>
+          </a:xfrm>
+          <a:prstGeom prst="rect">
+            <a:avLst/>
+          </a:prstGeom>
+          <a:noFill/>
+        </p:spPr>
+        <p:txBody>
+          <a:bodyPr wrap="square" lIns="0" rIns="0" tIns="0" bIns="0">
+            <a:spAutoFit/>
+          </a:bodyPr>
+          <a:lstStyle/>
+          <a:p>
+            <a:pPr>
+              <a:lnSpc>
+                <a:spcPct val="122000"/>
+              </a:lnSpc>
+              <a:spcAft>
+                <a:spcPts val="900"/>
+              </a:spcAft>
+              <a:defRPr sz="900" b="0">
+                <a:solidFill>
+                  <a:srgbClr val="C8FF32"/>
+                </a:solidFill>
+                <a:latin typeface="맑은 고딕"/>
+              </a:defRPr>
+            </a:pPr>
+            <a:r>
+              <a:t>AI BUILDERS LAB / 2026.09 · 현장 실습판</a:t>
+            </a:r>
+          </a:p>
+        </p:txBody>
+      </p:sp>
+      <p:sp>
+        <p:nvSpPr>
+          <p:cNvPr id="6" name="TextBox 5"/>
+          <p:cNvSpPr txBox="1"/>
+          <p:nvPr/>
+        </p:nvSpPr>
+        <p:spPr>
+          <a:xfrm>
+            <a:off x="10561320" y="6300216"/>
+            <a:ext cx="1005840" cy="292608"/>
+          </a:xfrm>
+          <a:prstGeom prst="rect">
+            <a:avLst/>
+          </a:prstGeom>
+          <a:noFill/>
+        </p:spPr>
+        <p:txBody>
+          <a:bodyPr wrap="square" lIns="0" rIns="0" tIns="0" bIns="0">
+            <a:spAutoFit/>
+          </a:bodyPr>
+          <a:lstStyle/>
+          <a:p>
+            <a:pPr>
+              <a:lnSpc>
+                <a:spcPct val="122000"/>
+              </a:lnSpc>
+              <a:spcAft>
+                <a:spcPts val="900"/>
+              </a:spcAft>
+              <a:defRPr sz="1200" b="1">
+                <a:solidFill>
+                  <a:srgbClr val="C8FF32"/>
+                </a:solidFill>
+                <a:latin typeface="맑은 고딕"/>
+              </a:defRPr>
+            </a:pPr>
+            <a:r>
+              <a:t>17 / 17</a:t>
             </a:r>
           </a:p>
         </p:txBody>
@@ -6921,7 +7273,7 @@
               </a:defRPr>
             </a:pPr>
             <a:r>
-              <a:t>02 / 16</a:t>
+              <a:t>02 / 17</a:t>
             </a:r>
           </a:p>
         </p:txBody>
@@ -7176,7 +7528,7 @@
               </a:defRPr>
             </a:pPr>
             <a:r>
-              <a:t>03 / 16</a:t>
+              <a:t>03 / 17</a:t>
             </a:r>
           </a:p>
         </p:txBody>
@@ -7431,7 +7783,7 @@
               </a:defRPr>
             </a:pPr>
             <a:r>
-              <a:t>04 / 16</a:t>
+              <a:t>04 / 17</a:t>
             </a:r>
           </a:p>
         </p:txBody>
@@ -7686,7 +8038,7 @@
               </a:defRPr>
             </a:pPr>
             <a:r>
-              <a:t>05 / 16</a:t>
+              <a:t>05 / 17</a:t>
             </a:r>
           </a:p>
         </p:txBody>
@@ -7941,7 +8293,7 @@
               </a:defRPr>
             </a:pPr>
             <a:r>
-              <a:t>06 / 16</a:t>
+              <a:t>06 / 17</a:t>
             </a:r>
           </a:p>
         </p:txBody>
@@ -8215,7 +8567,7 @@
               </a:defRPr>
             </a:pPr>
             <a:r>
-              <a:t>07 / 16</a:t>
+              <a:t>07 / 17</a:t>
             </a:r>
           </a:p>
         </p:txBody>
@@ -8470,7 +8822,7 @@
               </a:defRPr>
             </a:pPr>
             <a:r>
-              <a:t>08 / 16</a:t>
+              <a:t>08 / 17</a:t>
             </a:r>
           </a:p>
         </p:txBody>
@@ -8744,7 +9096,7 @@
               </a:defRPr>
             </a:pPr>
             <a:r>
-              <a:t>09 / 16</a:t>
+              <a:t>09 / 17</a:t>
             </a:r>
           </a:p>
         </p:txBody>

</xml_diff>